<commit_message>
Build the CV and a one-page resume from the PowerPoint source
</commit_message>
<xml_diff>
--- a/source-assets/cv/Martinez-CV.pptx
+++ b/source-assets/cv/Martinez-CV.pptx
@@ -5429,7 +5429,7 @@
         </p:nvSpPr>
         <p:spPr>
           <a:xfrm rot="0">
-            <a:off x="429768" y="1005840"/>
+            <a:off x="429768" y="950976"/>
             <a:ext cx="5120640" cy="174625"/>
           </a:xfrm>
           <a:prstGeom prst="rect">
@@ -5473,7 +5473,7 @@
         </p:nvSpPr>
         <p:spPr>
           <a:xfrm rot="0">
-            <a:off x="5294376" y="1005840"/>
+            <a:off x="5294376" y="950976"/>
             <a:ext cx="1801368" cy="165100"/>
           </a:xfrm>
           <a:prstGeom prst="rect">
@@ -5517,7 +5517,7 @@
         </p:nvSpPr>
         <p:spPr>
           <a:xfrm rot="0">
-            <a:off x="429768" y="1197864"/>
+            <a:off x="429768" y="1143000"/>
             <a:ext cx="6675120" cy="688975"/>
           </a:xfrm>
           <a:prstGeom prst="rect">
@@ -5560,7 +5560,7 @@
         </p:nvSpPr>
         <p:spPr>
           <a:xfrm rot="0">
-            <a:off x="429768" y="1389888"/>
+            <a:off x="429768" y="1335024"/>
             <a:ext cx="6675120" cy="688975"/>
           </a:xfrm>
           <a:prstGeom prst="rect">
@@ -5624,7 +5624,7 @@
         </p:nvSpPr>
         <p:spPr>
           <a:xfrm rot="0">
-            <a:off x="429768" y="2048256"/>
+            <a:off x="429768" y="2249424"/>
             <a:ext cx="5120640" cy="174625"/>
           </a:xfrm>
           <a:prstGeom prst="rect">
@@ -5668,7 +5668,7 @@
         </p:nvSpPr>
         <p:spPr>
           <a:xfrm rot="0">
-            <a:off x="5294376" y="2048256"/>
+            <a:off x="5294376" y="2249424"/>
             <a:ext cx="1801368" cy="165100"/>
           </a:xfrm>
           <a:prstGeom prst="rect">
@@ -5712,7 +5712,7 @@
         </p:nvSpPr>
         <p:spPr>
           <a:xfrm rot="0">
-            <a:off x="429768" y="2240280"/>
+            <a:off x="429768" y="2441448"/>
             <a:ext cx="6675120" cy="688975"/>
           </a:xfrm>
           <a:prstGeom prst="rect">
@@ -5755,7 +5755,7 @@
         </p:nvSpPr>
         <p:spPr>
           <a:xfrm rot="0">
-            <a:off x="429768" y="2432304"/>
+            <a:off x="429768" y="2633472"/>
             <a:ext cx="6675120" cy="688975"/>
           </a:xfrm>
           <a:prstGeom prst="rect">
@@ -5819,7 +5819,7 @@
         </p:nvSpPr>
         <p:spPr>
           <a:xfrm rot="0">
-            <a:off x="429768" y="3090672"/>
+            <a:off x="429768" y="3547872"/>
             <a:ext cx="5120640" cy="174625"/>
           </a:xfrm>
           <a:prstGeom prst="rect">
@@ -5863,7 +5863,7 @@
         </p:nvSpPr>
         <p:spPr>
           <a:xfrm rot="0">
-            <a:off x="5294376" y="3090672"/>
+            <a:off x="5294376" y="3547872"/>
             <a:ext cx="1801368" cy="165100"/>
           </a:xfrm>
           <a:prstGeom prst="rect">
@@ -5907,7 +5907,7 @@
         </p:nvSpPr>
         <p:spPr>
           <a:xfrm rot="0">
-            <a:off x="429768" y="3282696"/>
+            <a:off x="429768" y="3739896"/>
             <a:ext cx="6675120" cy="688975"/>
           </a:xfrm>
           <a:prstGeom prst="rect">
@@ -5950,7 +5950,7 @@
         </p:nvSpPr>
         <p:spPr>
           <a:xfrm rot="0">
-            <a:off x="429768" y="3474720"/>
+            <a:off x="429768" y="3931920"/>
             <a:ext cx="6675120" cy="688975"/>
           </a:xfrm>
           <a:prstGeom prst="rect">
@@ -6014,7 +6014,7 @@
         </p:nvSpPr>
         <p:spPr>
           <a:xfrm rot="0">
-            <a:off x="429768" y="4133088"/>
+            <a:off x="429768" y="4846320"/>
             <a:ext cx="5120640" cy="174625"/>
           </a:xfrm>
           <a:prstGeom prst="rect">
@@ -6058,7 +6058,7 @@
         </p:nvSpPr>
         <p:spPr>
           <a:xfrm rot="0">
-            <a:off x="5294376" y="4133088"/>
+            <a:off x="5294376" y="4846320"/>
             <a:ext cx="1801368" cy="165100"/>
           </a:xfrm>
           <a:prstGeom prst="rect">
@@ -6102,7 +6102,7 @@
         </p:nvSpPr>
         <p:spPr>
           <a:xfrm rot="0">
-            <a:off x="429768" y="4325112"/>
+            <a:off x="429768" y="5038344"/>
             <a:ext cx="6675120" cy="688975"/>
           </a:xfrm>
           <a:prstGeom prst="rect">
@@ -6145,7 +6145,7 @@
         </p:nvSpPr>
         <p:spPr>
           <a:xfrm rot="0">
-            <a:off x="429768" y="4517136"/>
+            <a:off x="429768" y="5230368"/>
             <a:ext cx="6675120" cy="688975"/>
           </a:xfrm>
           <a:prstGeom prst="rect">
@@ -6209,7 +6209,7 @@
         </p:nvSpPr>
         <p:spPr>
           <a:xfrm rot="0">
-            <a:off x="429768" y="5175504"/>
+            <a:off x="429768" y="5975604"/>
             <a:ext cx="5120640" cy="174625"/>
           </a:xfrm>
           <a:prstGeom prst="rect">
@@ -6253,7 +6253,7 @@
         </p:nvSpPr>
         <p:spPr>
           <a:xfrm rot="0">
-            <a:off x="5294376" y="5175504"/>
+            <a:off x="5294376" y="5975604"/>
             <a:ext cx="1801368" cy="165100"/>
           </a:xfrm>
           <a:prstGeom prst="rect">
@@ -6297,7 +6297,7 @@
         </p:nvSpPr>
         <p:spPr>
           <a:xfrm rot="0">
-            <a:off x="429768" y="5367528"/>
+            <a:off x="429768" y="6167628"/>
             <a:ext cx="6675120" cy="688975"/>
           </a:xfrm>
           <a:prstGeom prst="rect">
@@ -6340,7 +6340,7 @@
         </p:nvSpPr>
         <p:spPr>
           <a:xfrm rot="0">
-            <a:off x="429768" y="5559552"/>
+            <a:off x="429768" y="6359652"/>
             <a:ext cx="6675120" cy="688975"/>
           </a:xfrm>
           <a:prstGeom prst="rect">
@@ -6383,7 +6383,7 @@
         </p:nvSpPr>
         <p:spPr>
           <a:xfrm rot="0">
-            <a:off x="429768" y="6025896"/>
+            <a:off x="429768" y="6935724"/>
             <a:ext cx="5120640" cy="174625"/>
           </a:xfrm>
           <a:prstGeom prst="rect">
@@ -6427,7 +6427,7 @@
         </p:nvSpPr>
         <p:spPr>
           <a:xfrm rot="0">
-            <a:off x="5294376" y="6025896"/>
+            <a:off x="5294376" y="6935724"/>
             <a:ext cx="1801368" cy="165100"/>
           </a:xfrm>
           <a:prstGeom prst="rect">
@@ -6471,7 +6471,7 @@
         </p:nvSpPr>
         <p:spPr>
           <a:xfrm rot="0">
-            <a:off x="429768" y="6217920"/>
+            <a:off x="429768" y="7127748"/>
             <a:ext cx="6675120" cy="688975"/>
           </a:xfrm>
           <a:prstGeom prst="rect">
@@ -6514,7 +6514,7 @@
         </p:nvSpPr>
         <p:spPr>
           <a:xfrm rot="0">
-            <a:off x="429768" y="6409944"/>
+            <a:off x="429768" y="7319772"/>
             <a:ext cx="6675120" cy="688975"/>
           </a:xfrm>
           <a:prstGeom prst="rect">

</xml_diff>